<commit_message>
fixed tutorial and slides links
</commit_message>
<xml_diff>
--- a/Slides/Module 06 React Hook Patterns.pptx
+++ b/Slides/Module 06 React Hook Patterns.pptx
@@ -6858,7 +6858,7 @@
             </a:pPr>
             <a:r>
               <a:rPr lang="en-US" sz="2800" dirty="0"/>
-              <a:t>Adeel Bhutta, Rob Simmons and Mitch Wand</a:t>
+              <a:t>Adeel Bhutta and Mitch Wand</a:t>
             </a:r>
           </a:p>
           <a:p>
@@ -30291,7 +30291,7 @@
 </file>
 
 <file path=ppt/slides/slide36.xml><?xml version="1.0" encoding="utf-8"?>
-<p:sld xmlns:a="http://schemas.openxmlformats.org/drawingml/2006/main" xmlns:r="http://schemas.openxmlformats.org/officeDocument/2006/relationships" xmlns:p="http://schemas.openxmlformats.org/presentationml/2006/main" show="0">
+<p:sld xmlns:a="http://schemas.openxmlformats.org/drawingml/2006/main" xmlns:r="http://schemas.openxmlformats.org/officeDocument/2006/relationships" xmlns:p="http://schemas.openxmlformats.org/presentationml/2006/main">
   <p:cSld>
     <p:spTree>
       <p:nvGrpSpPr>
@@ -33832,8 +33832,8 @@
         </p:nvGrpSpPr>
         <p:grpSpPr>
           <a:xfrm>
-            <a:off x="1010798" y="4953968"/>
-            <a:ext cx="2797629" cy="1380023"/>
+            <a:off x="1096824" y="5283042"/>
+            <a:ext cx="2797629" cy="1016157"/>
             <a:chOff x="1687285" y="5076030"/>
             <a:chExt cx="2797629" cy="1380023"/>
           </a:xfrm>

</xml_diff>

<commit_message>
fixed missing source tag on s10
</commit_message>
<xml_diff>
--- a/Slides/Module 06 React Hook Patterns.pptx
+++ b/Slides/Module 06 React Hook Patterns.pptx
@@ -361,21 +361,12 @@
 </p:presentation>
 </file>
 
-<file path=ppt/revisionInfo.xml><?xml version="1.0" encoding="utf-8"?>
-<p1510:revInfo xmlns:a="http://schemas.openxmlformats.org/drawingml/2006/main" xmlns:r="http://schemas.openxmlformats.org/officeDocument/2006/relationships" xmlns:p1510="http://schemas.microsoft.com/office/powerpoint/2015/10/main">
-  <p1510:revLst>
-    <p1510:client id="{D3C33F09-918A-4894-B5A7-A18AE278568D}" v="4" dt="2026-09-20T17:21:33.290"/>
-    <p1510:client id="{D93C61A9-D69A-4A79-AD92-8D941EE6A321}" v="1" dt="2026-09-19T19:07:03.945"/>
-  </p1510:revLst>
-</p1510:revInfo>
-</file>
-
 <file path=ppt/changesInfos/changesInfo1.xml><?xml version="1.0" encoding="utf-8"?>
 <pc:chgInfo xmlns:a="http://schemas.openxmlformats.org/drawingml/2006/main" xmlns:r="http://schemas.openxmlformats.org/officeDocument/2006/relationships" xmlns:ac="http://schemas.microsoft.com/office/drawing/2013/main/command" xmlns:pc="http://schemas.microsoft.com/office/powerpoint/2013/main/command">
   <pc:docChgLst>
     <pc:chgData name="Mitchell Wand" userId="de9b44c55c049659" providerId="LiveId" clId="{7A9D5940-B2CC-47DD-AF5E-71219F1A1E26}"/>
     <pc:docChg chg="undo custSel addSld delSld modSld">
-      <pc:chgData name="Mitchell Wand" userId="de9b44c55c049659" providerId="LiveId" clId="{7A9D5940-B2CC-47DD-AF5E-71219F1A1E26}" dt="2026-09-20T17:21:33.290" v="646"/>
+      <pc:chgData name="Mitchell Wand" userId="de9b44c55c049659" providerId="LiveId" clId="{7A9D5940-B2CC-47DD-AF5E-71219F1A1E26}" dt="2026-09-25T23:40:01.247" v="677" actId="20577"/>
       <pc:docMkLst>
         <pc:docMk/>
       </pc:docMkLst>
@@ -385,14 +376,6 @@
           <pc:docMk/>
           <pc:sldMk cId="3886866829" sldId="424"/>
         </pc:sldMkLst>
-        <pc:spChg chg="del mod">
-          <ac:chgData name="Mitchell Wand" userId="de9b44c55c049659" providerId="LiveId" clId="{7A9D5940-B2CC-47DD-AF5E-71219F1A1E26}" dt="2026-09-20T14:38:40.092" v="571"/>
-          <ac:spMkLst>
-            <pc:docMk/>
-            <pc:sldMk cId="3886866829" sldId="424"/>
-            <ac:spMk id="4" creationId="{9C19FF8C-A42C-CC34-EA75-79137BA17575}"/>
-          </ac:spMkLst>
-        </pc:spChg>
         <pc:spChg chg="mod">
           <ac:chgData name="Mitchell Wand" userId="de9b44c55c049659" providerId="LiveId" clId="{7A9D5940-B2CC-47DD-AF5E-71219F1A1E26}" dt="2026-09-20T14:50:54.593" v="641" actId="6549"/>
           <ac:spMkLst>
@@ -460,22 +443,6 @@
             <pc:docMk/>
             <pc:sldMk cId="1941355569" sldId="437"/>
             <ac:picMk id="5" creationId="{FDC161F5-9355-5C32-07A8-05AD79375F18}"/>
-          </ac:picMkLst>
-        </pc:picChg>
-        <pc:picChg chg="del">
-          <ac:chgData name="Mitchell Wand" userId="de9b44c55c049659" providerId="LiveId" clId="{7A9D5940-B2CC-47DD-AF5E-71219F1A1E26}" dt="2026-09-20T13:59:18.126" v="536" actId="478"/>
-          <ac:picMkLst>
-            <pc:docMk/>
-            <pc:sldMk cId="1941355569" sldId="437"/>
-            <ac:picMk id="12" creationId="{E4A5DC3F-DA64-F3F4-C259-D31E218E9593}"/>
-          </ac:picMkLst>
-        </pc:picChg>
-        <pc:picChg chg="del">
-          <ac:chgData name="Mitchell Wand" userId="de9b44c55c049659" providerId="LiveId" clId="{7A9D5940-B2CC-47DD-AF5E-71219F1A1E26}" dt="2026-09-20T13:59:10.382" v="535" actId="478"/>
-          <ac:picMkLst>
-            <pc:docMk/>
-            <pc:sldMk cId="1941355569" sldId="437"/>
-            <ac:picMk id="14" creationId="{F547D154-4707-10B5-D8F5-17477BA742A7}"/>
           </ac:picMkLst>
         </pc:picChg>
       </pc:sldChg>
@@ -620,14 +587,6 @@
           <pc:docMk/>
           <pc:sldMk cId="2880220246" sldId="553"/>
         </pc:sldMkLst>
-        <pc:spChg chg="del">
-          <ac:chgData name="Mitchell Wand" userId="de9b44c55c049659" providerId="LiveId" clId="{7A9D5940-B2CC-47DD-AF5E-71219F1A1E26}" dt="2026-09-19T20:32:02.920" v="440" actId="478"/>
-          <ac:spMkLst>
-            <pc:docMk/>
-            <pc:sldMk cId="2880220246" sldId="553"/>
-            <ac:spMk id="2" creationId="{D9AE3514-1C8A-A1E1-A312-57C9EAF0B9E8}"/>
-          </ac:spMkLst>
-        </pc:spChg>
       </pc:sldChg>
       <pc:sldChg chg="modSp mod">
         <pc:chgData name="Mitchell Wand" userId="de9b44c55c049659" providerId="LiveId" clId="{7A9D5940-B2CC-47DD-AF5E-71219F1A1E26}" dt="2026-09-19T19:46:42.389" v="438" actId="20577"/>
@@ -666,6 +625,21 @@
           <pc:docMk/>
           <pc:sldMk cId="1926389287" sldId="557"/>
         </pc:sldMkLst>
+      </pc:sldChg>
+      <pc:sldChg chg="addSp modSp mod">
+        <pc:chgData name="Mitchell Wand" userId="de9b44c55c049659" providerId="LiveId" clId="{7A9D5940-B2CC-47DD-AF5E-71219F1A1E26}" dt="2026-09-25T23:40:01.247" v="677" actId="20577"/>
+        <pc:sldMkLst>
+          <pc:docMk/>
+          <pc:sldMk cId="3556445762" sldId="561"/>
+        </pc:sldMkLst>
+        <pc:spChg chg="add mod">
+          <ac:chgData name="Mitchell Wand" userId="de9b44c55c049659" providerId="LiveId" clId="{7A9D5940-B2CC-47DD-AF5E-71219F1A1E26}" dt="2026-09-25T23:40:01.247" v="677" actId="20577"/>
+          <ac:spMkLst>
+            <pc:docMk/>
+            <pc:sldMk cId="3556445762" sldId="561"/>
+            <ac:spMk id="6" creationId="{F7942C21-7C6F-D75E-27FC-69E811B88B96}"/>
+          </ac:spMkLst>
+        </pc:spChg>
       </pc:sldChg>
     </pc:docChg>
   </pc:docChgLst>
@@ -4758,7 +4732,7 @@
           <a:p>
             <a:fld id="{07C7BFD4-467E-4EDE-93EA-052F5B39A4E5}" type="datetime1">
               <a:rPr lang="en-US" smtClean="0"/>
-              <a:t>9/20/2026</a:t>
+              <a:t>9/25/2026</a:t>
             </a:fld>
             <a:endParaRPr lang="en-US"/>
           </a:p>
@@ -6218,7 +6192,7 @@
           </a:ln>
           <a:extLst>
             <a:ext uri="{C572A759-6A51-4108-AA02-DFA0A04FC94B}">
-              <ma14:wrappingTextBoxFlag xmlns="" xmlns:m="http://schemas.openxmlformats.org/officeDocument/2006/math" xmlns:a14="http://schemas.microsoft.com/office/drawing/2010/main" xmlns:ma14="http://schemas.microsoft.com/office/mac/drawingml/2011/main" val="1"/>
+              <ma14:wrappingTextBoxFlag xmlns:ma14="http://schemas.microsoft.com/office/mac/drawingml/2011/main" xmlns:a14="http://schemas.microsoft.com/office/drawing/2010/main" xmlns:m="http://schemas.openxmlformats.org/officeDocument/2006/math" xmlns="" val="1"/>
             </a:ext>
           </a:extLst>
         </p:spPr>
@@ -6329,7 +6303,7 @@
           </a:ln>
           <a:extLst>
             <a:ext uri="{C572A759-6A51-4108-AA02-DFA0A04FC94B}">
-              <ma14:wrappingTextBoxFlag xmlns="" xmlns:m="http://schemas.openxmlformats.org/officeDocument/2006/math" xmlns:a14="http://schemas.microsoft.com/office/drawing/2010/main" xmlns:ma14="http://schemas.microsoft.com/office/mac/drawingml/2011/main" val="1"/>
+              <ma14:wrappingTextBoxFlag xmlns:ma14="http://schemas.microsoft.com/office/mac/drawingml/2011/main" xmlns:a14="http://schemas.microsoft.com/office/drawing/2010/main" xmlns:m="http://schemas.openxmlformats.org/officeDocument/2006/math" xmlns="" val="1"/>
             </a:ext>
           </a:extLst>
         </p:spPr>
@@ -7220,7 +7194,7 @@
           </a:prstGeom>
           <a:extLst>
             <a:ext uri="{C572A759-6A51-4108-AA02-DFA0A04FC94B}">
-              <ma14:wrappingTextBoxFlag xmlns="" xmlns:m="http://schemas.openxmlformats.org/officeDocument/2006/math" xmlns:a14="http://schemas.microsoft.com/office/drawing/2010/main" xmlns:ma14="http://schemas.microsoft.com/office/mac/drawingml/2011/main" val="1"/>
+              <ma14:wrappingTextBoxFlag xmlns:ma14="http://schemas.microsoft.com/office/mac/drawingml/2011/main" xmlns:a14="http://schemas.microsoft.com/office/drawing/2010/main" xmlns:m="http://schemas.openxmlformats.org/officeDocument/2006/math" xmlns="" val="1"/>
             </a:ext>
           </a:extLst>
         </p:spPr>
@@ -7255,7 +7229,7 @@
           </a:ln>
           <a:extLst>
             <a:ext uri="{C572A759-6A51-4108-AA02-DFA0A04FC94B}">
-              <ma14:wrappingTextBoxFlag xmlns="" xmlns:m="http://schemas.openxmlformats.org/officeDocument/2006/math" xmlns:a14="http://schemas.microsoft.com/office/drawing/2010/main" xmlns:ma14="http://schemas.microsoft.com/office/mac/drawingml/2011/main" val="1"/>
+              <ma14:wrappingTextBoxFlag xmlns:ma14="http://schemas.microsoft.com/office/mac/drawingml/2011/main" xmlns:a14="http://schemas.microsoft.com/office/drawing/2010/main" xmlns:m="http://schemas.openxmlformats.org/officeDocument/2006/math" xmlns="" val="1"/>
             </a:ext>
           </a:extLst>
         </p:spPr>
@@ -8361,6 +8335,107 @@
               </a:rPr>
               <a:t>}</a:t>
             </a:r>
+          </a:p>
+        </p:txBody>
+      </p:sp>
+      <p:sp>
+        <p:nvSpPr>
+          <p:cNvPr id="6" name="Rectangle: Rounded Corners 5">
+            <a:extLst>
+              <a:ext uri="{FF2B5EF4-FFF2-40B4-BE49-F238E27FC236}">
+                <a16:creationId xmlns:a16="http://schemas.microsoft.com/office/drawing/2014/main" id="{F7942C21-7C6F-D75E-27FC-69E811B88B96}"/>
+              </a:ext>
+            </a:extLst>
+          </p:cNvPr>
+          <p:cNvSpPr/>
+          <p:nvPr/>
+        </p:nvSpPr>
+        <p:spPr>
+          <a:xfrm>
+            <a:off x="6772054" y="474493"/>
+            <a:ext cx="5419945" cy="601981"/>
+          </a:xfrm>
+          <a:prstGeom prst="roundRect">
+            <a:avLst/>
+          </a:prstGeom>
+          <a:solidFill>
+            <a:schemeClr val="accent6">
+              <a:lumMod val="20000"/>
+              <a:lumOff val="80000"/>
+            </a:schemeClr>
+          </a:solidFill>
+          <a:ln>
+            <a:solidFill>
+              <a:srgbClr val="0070C0"/>
+            </a:solidFill>
+          </a:ln>
+        </p:spPr>
+        <p:style>
+          <a:lnRef idx="2">
+            <a:schemeClr val="accent1">
+              <a:shade val="50000"/>
+            </a:schemeClr>
+          </a:lnRef>
+          <a:fillRef idx="1">
+            <a:schemeClr val="accent1"/>
+          </a:fillRef>
+          <a:effectRef idx="0">
+            <a:schemeClr val="accent1"/>
+          </a:effectRef>
+          <a:fontRef idx="minor">
+            <a:schemeClr val="lt1"/>
+          </a:fontRef>
+        </p:style>
+        <p:txBody>
+          <a:bodyPr rtlCol="0" anchor="ctr"/>
+          <a:lstStyle/>
+          <a:p>
+            <a:pPr algn="ctr"/>
+            <a:r>
+              <a:rPr lang="en-US" sz="2400" dirty="0" err="1">
+                <a:solidFill>
+                  <a:schemeClr val="tx1"/>
+                </a:solidFill>
+              </a:rPr>
+              <a:t>src</a:t>
+            </a:r>
+            <a:r>
+              <a:rPr lang="en-US" sz="2400" dirty="0">
+                <a:solidFill>
+                  <a:schemeClr val="tx1"/>
+                </a:solidFill>
+              </a:rPr>
+              <a:t>/Examples/</a:t>
+            </a:r>
+            <a:r>
+              <a:rPr lang="en-US" sz="2400" dirty="0" err="1">
+                <a:solidFill>
+                  <a:schemeClr val="tx1"/>
+                </a:solidFill>
+              </a:rPr>
+              <a:t>SimpleClock</a:t>
+            </a:r>
+            <a:r>
+              <a:rPr lang="en-US" sz="2400" dirty="0">
+                <a:solidFill>
+                  <a:schemeClr val="tx1"/>
+                </a:solidFill>
+              </a:rPr>
+              <a:t>/</a:t>
+            </a:r>
+            <a:r>
+              <a:rPr lang="en-US" sz="2400" dirty="0" err="1">
+                <a:solidFill>
+                  <a:schemeClr val="tx1"/>
+                </a:solidFill>
+              </a:rPr>
+              <a:t>App.tsx</a:t>
+            </a:r>
+            <a:endParaRPr lang="en-US" sz="2400" dirty="0">
+              <a:solidFill>
+                <a:schemeClr val="tx1"/>
+              </a:solidFill>
+            </a:endParaRPr>
           </a:p>
         </p:txBody>
       </p:sp>
@@ -28642,7 +28717,7 @@
           </a:prstGeom>
           <a:extLst>
             <a:ext uri="{C572A759-6A51-4108-AA02-DFA0A04FC94B}">
-              <ma14:wrappingTextBoxFlag xmlns="" xmlns:m="http://schemas.openxmlformats.org/officeDocument/2006/math" xmlns:a14="http://schemas.microsoft.com/office/drawing/2010/main" xmlns:ma14="http://schemas.microsoft.com/office/mac/drawingml/2011/main" val="1"/>
+              <ma14:wrappingTextBoxFlag xmlns:ma14="http://schemas.microsoft.com/office/mac/drawingml/2011/main" xmlns:a14="http://schemas.microsoft.com/office/drawing/2010/main" xmlns:m="http://schemas.openxmlformats.org/officeDocument/2006/math" xmlns="" val="1"/>
             </a:ext>
           </a:extLst>
         </p:spPr>
@@ -28683,7 +28758,7 @@
           </a:ln>
           <a:extLst>
             <a:ext uri="{C572A759-6A51-4108-AA02-DFA0A04FC94B}">
-              <ma14:wrappingTextBoxFlag xmlns="" xmlns:m="http://schemas.openxmlformats.org/officeDocument/2006/math" xmlns:a14="http://schemas.microsoft.com/office/drawing/2010/main" xmlns:ma14="http://schemas.microsoft.com/office/mac/drawingml/2011/main" val="1"/>
+              <ma14:wrappingTextBoxFlag xmlns:ma14="http://schemas.microsoft.com/office/mac/drawingml/2011/main" xmlns:a14="http://schemas.microsoft.com/office/drawing/2010/main" xmlns:m="http://schemas.openxmlformats.org/officeDocument/2006/math" xmlns="" val="1"/>
             </a:ext>
           </a:extLst>
         </p:spPr>
@@ -28973,7 +29048,7 @@
             <a:effectLst/>
             <a:extLst>
               <a:ext uri="{C572A759-6A51-4108-AA02-DFA0A04FC94B}">
-                <ma14:wrappingTextBoxFlag xmlns="" xmlns:m="http://schemas.openxmlformats.org/officeDocument/2006/math" xmlns:a14="http://schemas.microsoft.com/office/drawing/2010/main" xmlns:ma14="http://schemas.microsoft.com/office/mac/drawingml/2011/main" val="1"/>
+                <ma14:wrappingTextBoxFlag xmlns:ma14="http://schemas.microsoft.com/office/mac/drawingml/2011/main" xmlns:a14="http://schemas.microsoft.com/office/drawing/2010/main" xmlns:m="http://schemas.openxmlformats.org/officeDocument/2006/math" xmlns="" val="1"/>
               </a:ext>
             </a:extLst>
           </p:spPr>
@@ -29200,7 +29275,7 @@
           </a:prstGeom>
           <a:extLst>
             <a:ext uri="{C572A759-6A51-4108-AA02-DFA0A04FC94B}">
-              <ma14:wrappingTextBoxFlag xmlns="" xmlns:m="http://schemas.openxmlformats.org/officeDocument/2006/math" xmlns:a14="http://schemas.microsoft.com/office/drawing/2010/main" xmlns:ma14="http://schemas.microsoft.com/office/mac/drawingml/2011/main" val="1"/>
+              <ma14:wrappingTextBoxFlag xmlns:ma14="http://schemas.microsoft.com/office/mac/drawingml/2011/main" xmlns:a14="http://schemas.microsoft.com/office/drawing/2010/main" xmlns:m="http://schemas.openxmlformats.org/officeDocument/2006/math" xmlns="" val="1"/>
             </a:ext>
           </a:extLst>
         </p:spPr>
@@ -29959,7 +30034,7 @@
           </a:ln>
           <a:extLst>
             <a:ext uri="{C572A759-6A51-4108-AA02-DFA0A04FC94B}">
-              <ma14:wrappingTextBoxFlag xmlns="" xmlns:m="http://schemas.openxmlformats.org/officeDocument/2006/math" xmlns:a14="http://schemas.microsoft.com/office/drawing/2010/main" xmlns:ma14="http://schemas.microsoft.com/office/mac/drawingml/2011/main" val="1"/>
+              <ma14:wrappingTextBoxFlag xmlns:ma14="http://schemas.microsoft.com/office/mac/drawingml/2011/main" xmlns:a14="http://schemas.microsoft.com/office/drawing/2010/main" xmlns:m="http://schemas.openxmlformats.org/officeDocument/2006/math" xmlns="" val="1"/>
             </a:ext>
           </a:extLst>
         </p:spPr>
@@ -36362,7 +36437,7 @@
           </a:prstGeom>
           <a:extLst>
             <a:ext uri="{C572A759-6A51-4108-AA02-DFA0A04FC94B}">
-              <ma14:wrappingTextBoxFlag xmlns:ma14="http://schemas.microsoft.com/office/mac/drawingml/2011/main" xmlns:a14="http://schemas.microsoft.com/office/drawing/2010/main" xmlns:m="http://schemas.openxmlformats.org/officeDocument/2006/math" xmlns="" val="1"/>
+              <ma14:wrappingTextBoxFlag xmlns="" xmlns:m="http://schemas.openxmlformats.org/officeDocument/2006/math" xmlns:a14="http://schemas.microsoft.com/office/drawing/2010/main" xmlns:ma14="http://schemas.microsoft.com/office/mac/drawingml/2011/main" val="1"/>
             </a:ext>
           </a:extLst>
         </p:spPr>

</xml_diff>

<commit_message>
this is the right m06.pdf
</commit_message>
<xml_diff>
--- a/Slides/Module 06 React Hook Patterns.pptx
+++ b/Slides/Module 06 React Hook Patterns.pptx
@@ -361,21 +361,12 @@
 </p:presentation>
 </file>
 
-<file path=ppt/revisionInfo.xml><?xml version="1.0" encoding="utf-8"?>
-<p1510:revInfo xmlns:a="http://schemas.openxmlformats.org/drawingml/2006/main" xmlns:r="http://schemas.openxmlformats.org/officeDocument/2006/relationships" xmlns:p1510="http://schemas.microsoft.com/office/powerpoint/2015/10/main">
-  <p1510:revLst>
-    <p1510:client id="{D3C33F09-918A-4894-B5A7-A18AE278568D}" v="4" dt="2026-09-20T17:21:33.290"/>
-    <p1510:client id="{D93C61A9-D69A-4A79-AD92-8D941EE6A321}" v="1" dt="2026-09-19T19:07:03.945"/>
-  </p1510:revLst>
-</p1510:revInfo>
-</file>
-
 <file path=ppt/changesInfos/changesInfo1.xml><?xml version="1.0" encoding="utf-8"?>
 <pc:chgInfo xmlns:a="http://schemas.openxmlformats.org/drawingml/2006/main" xmlns:r="http://schemas.openxmlformats.org/officeDocument/2006/relationships" xmlns:ac="http://schemas.microsoft.com/office/drawing/2013/main/command" xmlns:pc="http://schemas.microsoft.com/office/powerpoint/2013/main/command">
   <pc:docChgLst>
     <pc:chgData name="Mitchell Wand" userId="de9b44c55c049659" providerId="LiveId" clId="{7A9D5940-B2CC-47DD-AF5E-71219F1A1E26}"/>
     <pc:docChg chg="undo custSel addSld delSld modSld">
-      <pc:chgData name="Mitchell Wand" userId="de9b44c55c049659" providerId="LiveId" clId="{7A9D5940-B2CC-47DD-AF5E-71219F1A1E26}" dt="2026-09-20T17:21:33.290" v="646"/>
+      <pc:chgData name="Mitchell Wand" userId="de9b44c55c049659" providerId="LiveId" clId="{7A9D5940-B2CC-47DD-AF5E-71219F1A1E26}" dt="2026-09-25T23:40:01.247" v="677" actId="20577"/>
       <pc:docMkLst>
         <pc:docMk/>
       </pc:docMkLst>
@@ -385,14 +376,6 @@
           <pc:docMk/>
           <pc:sldMk cId="3886866829" sldId="424"/>
         </pc:sldMkLst>
-        <pc:spChg chg="del mod">
-          <ac:chgData name="Mitchell Wand" userId="de9b44c55c049659" providerId="LiveId" clId="{7A9D5940-B2CC-47DD-AF5E-71219F1A1E26}" dt="2026-09-20T14:38:40.092" v="571"/>
-          <ac:spMkLst>
-            <pc:docMk/>
-            <pc:sldMk cId="3886866829" sldId="424"/>
-            <ac:spMk id="4" creationId="{9C19FF8C-A42C-CC34-EA75-79137BA17575}"/>
-          </ac:spMkLst>
-        </pc:spChg>
         <pc:spChg chg="mod">
           <ac:chgData name="Mitchell Wand" userId="de9b44c55c049659" providerId="LiveId" clId="{7A9D5940-B2CC-47DD-AF5E-71219F1A1E26}" dt="2026-09-20T14:50:54.593" v="641" actId="6549"/>
           <ac:spMkLst>
@@ -460,22 +443,6 @@
             <pc:docMk/>
             <pc:sldMk cId="1941355569" sldId="437"/>
             <ac:picMk id="5" creationId="{FDC161F5-9355-5C32-07A8-05AD79375F18}"/>
-          </ac:picMkLst>
-        </pc:picChg>
-        <pc:picChg chg="del">
-          <ac:chgData name="Mitchell Wand" userId="de9b44c55c049659" providerId="LiveId" clId="{7A9D5940-B2CC-47DD-AF5E-71219F1A1E26}" dt="2026-09-20T13:59:18.126" v="536" actId="478"/>
-          <ac:picMkLst>
-            <pc:docMk/>
-            <pc:sldMk cId="1941355569" sldId="437"/>
-            <ac:picMk id="12" creationId="{E4A5DC3F-DA64-F3F4-C259-D31E218E9593}"/>
-          </ac:picMkLst>
-        </pc:picChg>
-        <pc:picChg chg="del">
-          <ac:chgData name="Mitchell Wand" userId="de9b44c55c049659" providerId="LiveId" clId="{7A9D5940-B2CC-47DD-AF5E-71219F1A1E26}" dt="2026-09-20T13:59:10.382" v="535" actId="478"/>
-          <ac:picMkLst>
-            <pc:docMk/>
-            <pc:sldMk cId="1941355569" sldId="437"/>
-            <ac:picMk id="14" creationId="{F547D154-4707-10B5-D8F5-17477BA742A7}"/>
           </ac:picMkLst>
         </pc:picChg>
       </pc:sldChg>
@@ -620,14 +587,6 @@
           <pc:docMk/>
           <pc:sldMk cId="2880220246" sldId="553"/>
         </pc:sldMkLst>
-        <pc:spChg chg="del">
-          <ac:chgData name="Mitchell Wand" userId="de9b44c55c049659" providerId="LiveId" clId="{7A9D5940-B2CC-47DD-AF5E-71219F1A1E26}" dt="2026-09-19T20:32:02.920" v="440" actId="478"/>
-          <ac:spMkLst>
-            <pc:docMk/>
-            <pc:sldMk cId="2880220246" sldId="553"/>
-            <ac:spMk id="2" creationId="{D9AE3514-1C8A-A1E1-A312-57C9EAF0B9E8}"/>
-          </ac:spMkLst>
-        </pc:spChg>
       </pc:sldChg>
       <pc:sldChg chg="modSp mod">
         <pc:chgData name="Mitchell Wand" userId="de9b44c55c049659" providerId="LiveId" clId="{7A9D5940-B2CC-47DD-AF5E-71219F1A1E26}" dt="2026-09-19T19:46:42.389" v="438" actId="20577"/>
@@ -666,6 +625,21 @@
           <pc:docMk/>
           <pc:sldMk cId="1926389287" sldId="557"/>
         </pc:sldMkLst>
+      </pc:sldChg>
+      <pc:sldChg chg="addSp modSp mod">
+        <pc:chgData name="Mitchell Wand" userId="de9b44c55c049659" providerId="LiveId" clId="{7A9D5940-B2CC-47DD-AF5E-71219F1A1E26}" dt="2026-09-25T23:40:01.247" v="677" actId="20577"/>
+        <pc:sldMkLst>
+          <pc:docMk/>
+          <pc:sldMk cId="3556445762" sldId="561"/>
+        </pc:sldMkLst>
+        <pc:spChg chg="add mod">
+          <ac:chgData name="Mitchell Wand" userId="de9b44c55c049659" providerId="LiveId" clId="{7A9D5940-B2CC-47DD-AF5E-71219F1A1E26}" dt="2026-09-25T23:40:01.247" v="677" actId="20577"/>
+          <ac:spMkLst>
+            <pc:docMk/>
+            <pc:sldMk cId="3556445762" sldId="561"/>
+            <ac:spMk id="6" creationId="{F7942C21-7C6F-D75E-27FC-69E811B88B96}"/>
+          </ac:spMkLst>
+        </pc:spChg>
       </pc:sldChg>
     </pc:docChg>
   </pc:docChgLst>
@@ -4758,7 +4732,7 @@
           <a:p>
             <a:fld id="{07C7BFD4-467E-4EDE-93EA-052F5B39A4E5}" type="datetime1">
               <a:rPr lang="en-US" smtClean="0"/>
-              <a:t>9/20/2026</a:t>
+              <a:t>9/25/2026</a:t>
             </a:fld>
             <a:endParaRPr lang="en-US"/>
           </a:p>
@@ -6218,7 +6192,7 @@
           </a:ln>
           <a:extLst>
             <a:ext uri="{C572A759-6A51-4108-AA02-DFA0A04FC94B}">
-              <ma14:wrappingTextBoxFlag xmlns="" xmlns:m="http://schemas.openxmlformats.org/officeDocument/2006/math" xmlns:a14="http://schemas.microsoft.com/office/drawing/2010/main" xmlns:ma14="http://schemas.microsoft.com/office/mac/drawingml/2011/main" val="1"/>
+              <ma14:wrappingTextBoxFlag xmlns:ma14="http://schemas.microsoft.com/office/mac/drawingml/2011/main" xmlns:a14="http://schemas.microsoft.com/office/drawing/2010/main" xmlns:m="http://schemas.openxmlformats.org/officeDocument/2006/math" xmlns="" val="1"/>
             </a:ext>
           </a:extLst>
         </p:spPr>
@@ -6329,7 +6303,7 @@
           </a:ln>
           <a:extLst>
             <a:ext uri="{C572A759-6A51-4108-AA02-DFA0A04FC94B}">
-              <ma14:wrappingTextBoxFlag xmlns="" xmlns:m="http://schemas.openxmlformats.org/officeDocument/2006/math" xmlns:a14="http://schemas.microsoft.com/office/drawing/2010/main" xmlns:ma14="http://schemas.microsoft.com/office/mac/drawingml/2011/main" val="1"/>
+              <ma14:wrappingTextBoxFlag xmlns:ma14="http://schemas.microsoft.com/office/mac/drawingml/2011/main" xmlns:a14="http://schemas.microsoft.com/office/drawing/2010/main" xmlns:m="http://schemas.openxmlformats.org/officeDocument/2006/math" xmlns="" val="1"/>
             </a:ext>
           </a:extLst>
         </p:spPr>
@@ -7220,7 +7194,7 @@
           </a:prstGeom>
           <a:extLst>
             <a:ext uri="{C572A759-6A51-4108-AA02-DFA0A04FC94B}">
-              <ma14:wrappingTextBoxFlag xmlns="" xmlns:m="http://schemas.openxmlformats.org/officeDocument/2006/math" xmlns:a14="http://schemas.microsoft.com/office/drawing/2010/main" xmlns:ma14="http://schemas.microsoft.com/office/mac/drawingml/2011/main" val="1"/>
+              <ma14:wrappingTextBoxFlag xmlns:ma14="http://schemas.microsoft.com/office/mac/drawingml/2011/main" xmlns:a14="http://schemas.microsoft.com/office/drawing/2010/main" xmlns:m="http://schemas.openxmlformats.org/officeDocument/2006/math" xmlns="" val="1"/>
             </a:ext>
           </a:extLst>
         </p:spPr>
@@ -7255,7 +7229,7 @@
           </a:ln>
           <a:extLst>
             <a:ext uri="{C572A759-6A51-4108-AA02-DFA0A04FC94B}">
-              <ma14:wrappingTextBoxFlag xmlns="" xmlns:m="http://schemas.openxmlformats.org/officeDocument/2006/math" xmlns:a14="http://schemas.microsoft.com/office/drawing/2010/main" xmlns:ma14="http://schemas.microsoft.com/office/mac/drawingml/2011/main" val="1"/>
+              <ma14:wrappingTextBoxFlag xmlns:ma14="http://schemas.microsoft.com/office/mac/drawingml/2011/main" xmlns:a14="http://schemas.microsoft.com/office/drawing/2010/main" xmlns:m="http://schemas.openxmlformats.org/officeDocument/2006/math" xmlns="" val="1"/>
             </a:ext>
           </a:extLst>
         </p:spPr>
@@ -8361,6 +8335,107 @@
               </a:rPr>
               <a:t>}</a:t>
             </a:r>
+          </a:p>
+        </p:txBody>
+      </p:sp>
+      <p:sp>
+        <p:nvSpPr>
+          <p:cNvPr id="6" name="Rectangle: Rounded Corners 5">
+            <a:extLst>
+              <a:ext uri="{FF2B5EF4-FFF2-40B4-BE49-F238E27FC236}">
+                <a16:creationId xmlns:a16="http://schemas.microsoft.com/office/drawing/2014/main" id="{F7942C21-7C6F-D75E-27FC-69E811B88B96}"/>
+              </a:ext>
+            </a:extLst>
+          </p:cNvPr>
+          <p:cNvSpPr/>
+          <p:nvPr/>
+        </p:nvSpPr>
+        <p:spPr>
+          <a:xfrm>
+            <a:off x="6772054" y="474493"/>
+            <a:ext cx="5419945" cy="601981"/>
+          </a:xfrm>
+          <a:prstGeom prst="roundRect">
+            <a:avLst/>
+          </a:prstGeom>
+          <a:solidFill>
+            <a:schemeClr val="accent6">
+              <a:lumMod val="20000"/>
+              <a:lumOff val="80000"/>
+            </a:schemeClr>
+          </a:solidFill>
+          <a:ln>
+            <a:solidFill>
+              <a:srgbClr val="0070C0"/>
+            </a:solidFill>
+          </a:ln>
+        </p:spPr>
+        <p:style>
+          <a:lnRef idx="2">
+            <a:schemeClr val="accent1">
+              <a:shade val="50000"/>
+            </a:schemeClr>
+          </a:lnRef>
+          <a:fillRef idx="1">
+            <a:schemeClr val="accent1"/>
+          </a:fillRef>
+          <a:effectRef idx="0">
+            <a:schemeClr val="accent1"/>
+          </a:effectRef>
+          <a:fontRef idx="minor">
+            <a:schemeClr val="lt1"/>
+          </a:fontRef>
+        </p:style>
+        <p:txBody>
+          <a:bodyPr rtlCol="0" anchor="ctr"/>
+          <a:lstStyle/>
+          <a:p>
+            <a:pPr algn="ctr"/>
+            <a:r>
+              <a:rPr lang="en-US" sz="2400" dirty="0" err="1">
+                <a:solidFill>
+                  <a:schemeClr val="tx1"/>
+                </a:solidFill>
+              </a:rPr>
+              <a:t>src</a:t>
+            </a:r>
+            <a:r>
+              <a:rPr lang="en-US" sz="2400" dirty="0">
+                <a:solidFill>
+                  <a:schemeClr val="tx1"/>
+                </a:solidFill>
+              </a:rPr>
+              <a:t>/Examples/</a:t>
+            </a:r>
+            <a:r>
+              <a:rPr lang="en-US" sz="2400" dirty="0" err="1">
+                <a:solidFill>
+                  <a:schemeClr val="tx1"/>
+                </a:solidFill>
+              </a:rPr>
+              <a:t>SimpleClock</a:t>
+            </a:r>
+            <a:r>
+              <a:rPr lang="en-US" sz="2400" dirty="0">
+                <a:solidFill>
+                  <a:schemeClr val="tx1"/>
+                </a:solidFill>
+              </a:rPr>
+              <a:t>/</a:t>
+            </a:r>
+            <a:r>
+              <a:rPr lang="en-US" sz="2400" dirty="0" err="1">
+                <a:solidFill>
+                  <a:schemeClr val="tx1"/>
+                </a:solidFill>
+              </a:rPr>
+              <a:t>App.tsx</a:t>
+            </a:r>
+            <a:endParaRPr lang="en-US" sz="2400" dirty="0">
+              <a:solidFill>
+                <a:schemeClr val="tx1"/>
+              </a:solidFill>
+            </a:endParaRPr>
           </a:p>
         </p:txBody>
       </p:sp>
@@ -28642,7 +28717,7 @@
           </a:prstGeom>
           <a:extLst>
             <a:ext uri="{C572A759-6A51-4108-AA02-DFA0A04FC94B}">
-              <ma14:wrappingTextBoxFlag xmlns="" xmlns:m="http://schemas.openxmlformats.org/officeDocument/2006/math" xmlns:a14="http://schemas.microsoft.com/office/drawing/2010/main" xmlns:ma14="http://schemas.microsoft.com/office/mac/drawingml/2011/main" val="1"/>
+              <ma14:wrappingTextBoxFlag xmlns:ma14="http://schemas.microsoft.com/office/mac/drawingml/2011/main" xmlns:a14="http://schemas.microsoft.com/office/drawing/2010/main" xmlns:m="http://schemas.openxmlformats.org/officeDocument/2006/math" xmlns="" val="1"/>
             </a:ext>
           </a:extLst>
         </p:spPr>
@@ -28683,7 +28758,7 @@
           </a:ln>
           <a:extLst>
             <a:ext uri="{C572A759-6A51-4108-AA02-DFA0A04FC94B}">
-              <ma14:wrappingTextBoxFlag xmlns="" xmlns:m="http://schemas.openxmlformats.org/officeDocument/2006/math" xmlns:a14="http://schemas.microsoft.com/office/drawing/2010/main" xmlns:ma14="http://schemas.microsoft.com/office/mac/drawingml/2011/main" val="1"/>
+              <ma14:wrappingTextBoxFlag xmlns:ma14="http://schemas.microsoft.com/office/mac/drawingml/2011/main" xmlns:a14="http://schemas.microsoft.com/office/drawing/2010/main" xmlns:m="http://schemas.openxmlformats.org/officeDocument/2006/math" xmlns="" val="1"/>
             </a:ext>
           </a:extLst>
         </p:spPr>
@@ -28973,7 +29048,7 @@
             <a:effectLst/>
             <a:extLst>
               <a:ext uri="{C572A759-6A51-4108-AA02-DFA0A04FC94B}">
-                <ma14:wrappingTextBoxFlag xmlns="" xmlns:m="http://schemas.openxmlformats.org/officeDocument/2006/math" xmlns:a14="http://schemas.microsoft.com/office/drawing/2010/main" xmlns:ma14="http://schemas.microsoft.com/office/mac/drawingml/2011/main" val="1"/>
+                <ma14:wrappingTextBoxFlag xmlns:ma14="http://schemas.microsoft.com/office/mac/drawingml/2011/main" xmlns:a14="http://schemas.microsoft.com/office/drawing/2010/main" xmlns:m="http://schemas.openxmlformats.org/officeDocument/2006/math" xmlns="" val="1"/>
               </a:ext>
             </a:extLst>
           </p:spPr>
@@ -29200,7 +29275,7 @@
           </a:prstGeom>
           <a:extLst>
             <a:ext uri="{C572A759-6A51-4108-AA02-DFA0A04FC94B}">
-              <ma14:wrappingTextBoxFlag xmlns="" xmlns:m="http://schemas.openxmlformats.org/officeDocument/2006/math" xmlns:a14="http://schemas.microsoft.com/office/drawing/2010/main" xmlns:ma14="http://schemas.microsoft.com/office/mac/drawingml/2011/main" val="1"/>
+              <ma14:wrappingTextBoxFlag xmlns:ma14="http://schemas.microsoft.com/office/mac/drawingml/2011/main" xmlns:a14="http://schemas.microsoft.com/office/drawing/2010/main" xmlns:m="http://schemas.openxmlformats.org/officeDocument/2006/math" xmlns="" val="1"/>
             </a:ext>
           </a:extLst>
         </p:spPr>
@@ -29959,7 +30034,7 @@
           </a:ln>
           <a:extLst>
             <a:ext uri="{C572A759-6A51-4108-AA02-DFA0A04FC94B}">
-              <ma14:wrappingTextBoxFlag xmlns="" xmlns:m="http://schemas.openxmlformats.org/officeDocument/2006/math" xmlns:a14="http://schemas.microsoft.com/office/drawing/2010/main" xmlns:ma14="http://schemas.microsoft.com/office/mac/drawingml/2011/main" val="1"/>
+              <ma14:wrappingTextBoxFlag xmlns:ma14="http://schemas.microsoft.com/office/mac/drawingml/2011/main" xmlns:a14="http://schemas.microsoft.com/office/drawing/2010/main" xmlns:m="http://schemas.openxmlformats.org/officeDocument/2006/math" xmlns="" val="1"/>
             </a:ext>
           </a:extLst>
         </p:spPr>
@@ -36362,7 +36437,7 @@
           </a:prstGeom>
           <a:extLst>
             <a:ext uri="{C572A759-6A51-4108-AA02-DFA0A04FC94B}">
-              <ma14:wrappingTextBoxFlag xmlns:ma14="http://schemas.microsoft.com/office/mac/drawingml/2011/main" xmlns:a14="http://schemas.microsoft.com/office/drawing/2010/main" xmlns:m="http://schemas.openxmlformats.org/officeDocument/2006/math" xmlns="" val="1"/>
+              <ma14:wrappingTextBoxFlag xmlns="" xmlns:m="http://schemas.openxmlformats.org/officeDocument/2006/math" xmlns:a14="http://schemas.microsoft.com/office/drawing/2010/main" xmlns:ma14="http://schemas.microsoft.com/office/mac/drawingml/2011/main" val="1"/>
             </a:ext>
           </a:extLst>
         </p:spPr>

</xml_diff>